<commit_message>
add all new files
</commit_message>
<xml_diff>
--- a/TOP_Digital_Twin_PI_Review_Final.pptx
+++ b/TOP_Digital_Twin_PI_Review_Final.pptx
@@ -138,6 +138,9 @@
           </p15:clr>
         </p15:guide>
       </p15:sldGuideLst>
+    </p:ext>
+    <p:ext uri="{2D200454-40CA-4A62-9FC3-DE9A4176ACB9}">
+      <p15:notesGuideLst xmlns:p15="http://schemas.microsoft.com/office/powerpoint/2012/main"/>
     </p:ext>
   </p:extLst>
 </p:presentation>
@@ -4588,7 +4591,7 @@
           <a:p>
             <a:fld id="{5BCAD085-E8A6-8845-BD4E-CB4CCA059FC4}" type="datetimeFigureOut">
               <a:rPr lang="en-US" smtClean="0"/>
-              <a:t>7/20/2026</a:t>
+              <a:t>7/21/2026</a:t>
             </a:fld>
             <a:endParaRPr lang="en-US"/>
           </a:p>
@@ -4756,7 +4759,7 @@
           <a:p>
             <a:fld id="{5BCAD085-E8A6-8845-BD4E-CB4CCA059FC4}" type="datetimeFigureOut">
               <a:rPr lang="en-US" smtClean="0"/>
-              <a:t>7/20/2026</a:t>
+              <a:t>7/21/2026</a:t>
             </a:fld>
             <a:endParaRPr lang="en-US"/>
           </a:p>
@@ -4934,7 +4937,7 @@
           <a:p>
             <a:fld id="{5BCAD085-E8A6-8845-BD4E-CB4CCA059FC4}" type="datetimeFigureOut">
               <a:rPr lang="en-US" smtClean="0"/>
-              <a:t>7/20/2026</a:t>
+              <a:t>7/21/2026</a:t>
             </a:fld>
             <a:endParaRPr lang="en-US"/>
           </a:p>
@@ -5102,7 +5105,7 @@
           <a:p>
             <a:fld id="{5BCAD085-E8A6-8845-BD4E-CB4CCA059FC4}" type="datetimeFigureOut">
               <a:rPr lang="en-US" smtClean="0"/>
-              <a:t>7/20/2026</a:t>
+              <a:t>7/21/2026</a:t>
             </a:fld>
             <a:endParaRPr lang="en-US"/>
           </a:p>
@@ -5347,7 +5350,7 @@
           <a:p>
             <a:fld id="{5BCAD085-E8A6-8845-BD4E-CB4CCA059FC4}" type="datetimeFigureOut">
               <a:rPr lang="en-US" smtClean="0"/>
-              <a:t>7/20/2026</a:t>
+              <a:t>7/21/2026</a:t>
             </a:fld>
             <a:endParaRPr lang="en-US"/>
           </a:p>
@@ -5632,7 +5635,7 @@
           <a:p>
             <a:fld id="{5BCAD085-E8A6-8845-BD4E-CB4CCA059FC4}" type="datetimeFigureOut">
               <a:rPr lang="en-US" smtClean="0"/>
-              <a:t>7/20/2026</a:t>
+              <a:t>7/21/2026</a:t>
             </a:fld>
             <a:endParaRPr lang="en-US"/>
           </a:p>
@@ -6051,7 +6054,7 @@
           <a:p>
             <a:fld id="{5BCAD085-E8A6-8845-BD4E-CB4CCA059FC4}" type="datetimeFigureOut">
               <a:rPr lang="en-US" smtClean="0"/>
-              <a:t>7/20/2026</a:t>
+              <a:t>7/21/2026</a:t>
             </a:fld>
             <a:endParaRPr lang="en-US"/>
           </a:p>
@@ -6168,7 +6171,7 @@
           <a:p>
             <a:fld id="{5BCAD085-E8A6-8845-BD4E-CB4CCA059FC4}" type="datetimeFigureOut">
               <a:rPr lang="en-US" smtClean="0"/>
-              <a:t>7/20/2026</a:t>
+              <a:t>7/21/2026</a:t>
             </a:fld>
             <a:endParaRPr lang="en-US"/>
           </a:p>
@@ -6263,7 +6266,7 @@
           <a:p>
             <a:fld id="{5BCAD085-E8A6-8845-BD4E-CB4CCA059FC4}" type="datetimeFigureOut">
               <a:rPr lang="en-US" smtClean="0"/>
-              <a:t>7/20/2026</a:t>
+              <a:t>7/21/2026</a:t>
             </a:fld>
             <a:endParaRPr lang="en-US"/>
           </a:p>
@@ -6538,7 +6541,7 @@
           <a:p>
             <a:fld id="{5BCAD085-E8A6-8845-BD4E-CB4CCA059FC4}" type="datetimeFigureOut">
               <a:rPr lang="en-US" smtClean="0"/>
-              <a:t>7/20/2026</a:t>
+              <a:t>7/21/2026</a:t>
             </a:fld>
             <a:endParaRPr lang="en-US"/>
           </a:p>
@@ -6790,7 +6793,7 @@
           <a:p>
             <a:fld id="{5BCAD085-E8A6-8845-BD4E-CB4CCA059FC4}" type="datetimeFigureOut">
               <a:rPr lang="en-US" smtClean="0"/>
-              <a:t>7/20/2026</a:t>
+              <a:t>7/21/2026</a:t>
             </a:fld>
             <a:endParaRPr lang="en-US"/>
           </a:p>
@@ -7001,7 +7004,7 @@
           <a:p>
             <a:fld id="{5BCAD085-E8A6-8845-BD4E-CB4CCA059FC4}" type="datetimeFigureOut">
               <a:rPr lang="en-US" smtClean="0"/>
-              <a:t>7/20/2026</a:t>
+              <a:t>7/21/2026</a:t>
             </a:fld>
             <a:endParaRPr lang="en-US"/>
           </a:p>
@@ -36214,7 +36217,7 @@
         <p:spPr>
           <a:xfrm>
             <a:off x="320040" y="3648456"/>
-            <a:ext cx="5303520" cy="274320"/>
+            <a:ext cx="5303520" cy="246221"/>
           </a:xfrm>
           <a:prstGeom prst="rect">
             <a:avLst/>
@@ -36229,13 +36232,22 @@
           <a:p>
             <a:pPr algn="l"/>
             <a:r>
-              <a:rPr sz="1000" b="1" i="0">
+              <a:rPr lang="en-US" sz="1000" b="1" dirty="0">
                 <a:solidFill>
                   <a:srgbClr val="FFFFFF"/>
                 </a:solidFill>
                 <a:latin typeface="Calibri"/>
               </a:rPr>
-              <a:t>PI BRIEF RECOMMENDATION</a:t>
+              <a:t>EARLIER </a:t>
+            </a:r>
+            <a:r>
+              <a:rPr sz="1000" b="1" i="0" dirty="0">
+                <a:solidFill>
+                  <a:srgbClr val="FFFFFF"/>
+                </a:solidFill>
+                <a:latin typeface="Calibri"/>
+              </a:rPr>
+              <a:t>RECOMMENDATION</a:t>
             </a:r>
           </a:p>
         </p:txBody>
@@ -36410,7 +36422,7 @@
         <p:spPr>
           <a:xfrm>
             <a:off x="6126480" y="3648456"/>
-            <a:ext cx="5669280" cy="274320"/>
+            <a:ext cx="5669280" cy="246221"/>
           </a:xfrm>
           <a:prstGeom prst="rect">
             <a:avLst/>
@@ -36425,14 +36437,29 @@
           <a:p>
             <a:pPr algn="l"/>
             <a:r>
-              <a:rPr sz="1000" b="1" i="0">
+              <a:rPr sz="1000" b="1" i="0" dirty="0">
                 <a:solidFill>
                   <a:srgbClr val="FFFFFF"/>
                 </a:solidFill>
                 <a:latin typeface="Calibri"/>
               </a:rPr>
-              <a:t>OUR DECISION — FULL PANEL  (approved)</a:t>
-            </a:r>
+              <a:t>OUR DECISION — FULL PANE</a:t>
+            </a:r>
+            <a:r>
+              <a:rPr lang="en-US" sz="1000" b="1" i="0" dirty="0">
+                <a:solidFill>
+                  <a:srgbClr val="FFFFFF"/>
+                </a:solidFill>
+                <a:latin typeface="Calibri"/>
+              </a:rPr>
+              <a:t>L</a:t>
+            </a:r>
+            <a:endParaRPr sz="1000" b="1" i="0" dirty="0">
+              <a:solidFill>
+                <a:srgbClr val="FFFFFF"/>
+              </a:solidFill>
+              <a:latin typeface="Calibri"/>
+            </a:endParaRPr>
           </a:p>
         </p:txBody>
       </p:sp>

</xml_diff>